<commit_message>
feat: implement agent run recovery services and add smoke tests for failure handling workflows
</commit_message>
<xml_diff>
--- a/docs/presentations/aligna-professor-deck/Aligna_Apresentacao_Professor.pptx
+++ b/docs/presentations/aligna-professor-deck/Aligna_Apresentacao_Professor.pptx
@@ -17,9 +17,10 @@
     <p:sldId id="265" r:id="rId11"/>
     <p:sldId id="266" r:id="rId12"/>
     <p:sldId id="267" r:id="rId13"/>
+    <p:sldId id="268" r:id="rId14"/>
   </p:sldIdLst>
   <p:notesMasterIdLst>
-    <p:notesMasterId r:id="rId14"/>
+    <p:notesMasterId r:id="rId15"/>
   </p:notesMasterIdLst>
   <p:sldSz cx="12192000" cy="6858000"/>
   <p:notesSz cx="6858000" cy="12192000"/>
@@ -801,6 +802,94 @@
             <a:fld id="{F7021451-1387-4CA6-816F-3879F97B5CBC}" type="slidenum">
               <a:rPr lang="en-US"/>
               <a:t>12</a:t>
+            </a:fld>
+            <a:endParaRPr lang="en-US"/>
+          </a:p>
+        </p:txBody>
+      </p:sp>
+    </p:spTree>
+    <p:extLst>
+      <p:ext uri="{BB962C8B-B14F-4D97-AF65-F5344CB8AC3E}">
+        <p14:creationId xmlns:p14="http://schemas.microsoft.com/office/powerpoint/2010/main" val="1024086991"/>
+      </p:ext>
+    </p:extLst>
+  </p:cSld>
+  <p:clrMapOvr>
+    <a:masterClrMapping/>
+  </p:clrMapOvr>
+</p:notes>
+</file>
+
+<file path=ppt/notesSlides/notesSlide13.xml><?xml version="1.0" encoding="utf-8"?>
+<p:notes xmlns:a="http://schemas.openxmlformats.org/drawingml/2006/main" xmlns:r="http://schemas.openxmlformats.org/officeDocument/2006/relationships" xmlns:p="http://schemas.openxmlformats.org/presentationml/2006/main">
+  <p:cSld>
+    <p:spTree>
+      <p:nvGrpSpPr>
+        <p:cNvPr id="1" name=""/>
+        <p:cNvGrpSpPr/>
+        <p:nvPr/>
+      </p:nvGrpSpPr>
+      <p:grpSpPr>
+        <a:xfrm>
+          <a:off x="0" y="0"/>
+          <a:ext cx="0" cy="0"/>
+          <a:chOff x="0" y="0"/>
+          <a:chExt cx="0" cy="0"/>
+        </a:xfrm>
+      </p:grpSpPr>
+      <p:sp>
+        <p:nvSpPr>
+          <p:cNvPr id="2" name="Slide Image Placeholder 1"/>
+          <p:cNvSpPr>
+            <a:spLocks noGrp="1" noRot="1" noChangeAspect="1"/>
+          </p:cNvSpPr>
+          <p:nvPr>
+            <p:ph type="sldImg"/>
+          </p:nvPr>
+        </p:nvSpPr>
+        <p:spPr/>
+      </p:sp>
+      <p:sp>
+        <p:nvSpPr>
+          <p:cNvPr id="3" name="Notes Placeholder 2"/>
+          <p:cNvSpPr>
+            <a:spLocks noGrp="1"/>
+          </p:cNvSpPr>
+          <p:nvPr>
+            <p:ph type="body" idx="1"/>
+          </p:nvPr>
+        </p:nvSpPr>
+        <p:spPr/>
+        <p:txBody>
+          <a:bodyPr/>
+          <a:lstStyle/>
+          <a:p>
+            <a:r>
+              <a:rPr lang="en-US" dirty="0"/>
+              <a:t/>
+            </a:r>
+            <a:endParaRPr lang="en-US" dirty="0"/>
+          </a:p>
+        </p:txBody>
+      </p:sp>
+      <p:sp>
+        <p:nvSpPr>
+          <p:cNvPr id="4" name="Slide Number Placeholder 3"/>
+          <p:cNvSpPr>
+            <a:spLocks noGrp="1"/>
+          </p:cNvSpPr>
+          <p:nvPr>
+            <p:ph type="sldNum" sz="quarter" idx="10"/>
+          </p:nvPr>
+        </p:nvSpPr>
+        <p:spPr/>
+        <p:txBody>
+          <a:bodyPr/>
+          <a:lstStyle/>
+          <a:p>
+            <a:fld id="{F7021451-1387-4CA6-816F-3879F97B5CBC}" type="slidenum">
+              <a:rPr lang="en-US"/>
+              <a:t>13</a:t>
             </a:fld>
             <a:endParaRPr lang="en-US"/>
           </a:p>
@@ -3925,6 +4014,1213 @@
     <p:bg>
       <p:bgPr>
         <a:solidFill>
+          <a:srgbClr val="FFFFFF"/>
+        </a:solidFill>
+      </p:bgPr>
+    </p:bg>
+    <p:spTree>
+      <p:nvGrpSpPr>
+        <p:cNvPr id="1" name=""/>
+        <p:cNvGrpSpPr/>
+        <p:nvPr/>
+      </p:nvGrpSpPr>
+      <p:grpSpPr>
+        <a:xfrm>
+          <a:off x="0" y="0"/>
+          <a:ext cx="0" cy="0"/>
+          <a:chOff x="0" y="0"/>
+          <a:chExt cx="0" cy="0"/>
+        </a:xfrm>
+      </p:grpSpPr>
+      <p:sp>
+        <p:nvSpPr>
+          <p:cNvPr id="2" name="Shape 0"/>
+          <p:cNvSpPr/>
+          <p:nvPr/>
+        </p:nvSpPr>
+        <p:spPr>
+          <a:xfrm>
+            <a:off x="0" y="0"/>
+            <a:ext cx="12191695" cy="548640"/>
+          </a:xfrm>
+          <a:prstGeom prst="rect">
+            <a:avLst/>
+          </a:prstGeom>
+          <a:solidFill>
+            <a:srgbClr val="0F172A"/>
+          </a:solidFill>
+          <a:ln w="12700">
+            <a:solidFill>
+              <a:srgbClr val="0F172A">
+                <a:alpha val="0"/>
+              </a:srgbClr>
+            </a:solidFill>
+            <a:prstDash val="solid"/>
+          </a:ln>
+        </p:spPr>
+      </p:sp>
+      <p:sp>
+        <p:nvSpPr>
+          <p:cNvPr id="3" name="Text 1"/>
+          <p:cNvSpPr/>
+          <p:nvPr/>
+        </p:nvSpPr>
+        <p:spPr>
+          <a:xfrm>
+            <a:off x="502920" y="182880"/>
+            <a:ext cx="2926080" cy="164592"/>
+          </a:xfrm>
+          <a:prstGeom prst="rect">
+            <a:avLst/>
+          </a:prstGeom>
+          <a:noFill/>
+          <a:ln/>
+        </p:spPr>
+        <p:txBody>
+          <a:bodyPr wrap="square" rtlCol="0" anchor="ctr"/>
+          <a:lstStyle/>
+          <a:p>
+            <a:pPr indent="0" marL="0">
+              <a:buNone/>
+            </a:pPr>
+            <a:r>
+              <a:rPr lang="en-US" sz="1100" b="1" dirty="0">
+                <a:solidFill>
+                  <a:srgbClr val="D1FAE5"/>
+                </a:solidFill>
+                <a:latin typeface="Arial" pitchFamily="34" charset="0"/>
+                <a:ea typeface="Arial" pitchFamily="34" charset="-122"/>
+                <a:cs typeface="Arial" pitchFamily="34" charset="-120"/>
+              </a:rPr>
+              <a:t>LEITURA EXECUTIVA</a:t>
+            </a:r>
+            <a:endParaRPr lang="en-US" sz="1100" dirty="0"/>
+          </a:p>
+        </p:txBody>
+      </p:sp>
+      <p:sp>
+        <p:nvSpPr>
+          <p:cNvPr id="4" name="Text 2"/>
+          <p:cNvSpPr/>
+          <p:nvPr/>
+        </p:nvSpPr>
+        <p:spPr>
+          <a:xfrm>
+            <a:off x="502920" y="749808"/>
+            <a:ext cx="8138160" cy="411480"/>
+          </a:xfrm>
+          <a:prstGeom prst="rect">
+            <a:avLst/>
+          </a:prstGeom>
+          <a:noFill/>
+          <a:ln/>
+        </p:spPr>
+        <p:txBody>
+          <a:bodyPr wrap="square" rtlCol="0" anchor="ctr"/>
+          <a:lstStyle/>
+          <a:p>
+            <a:pPr indent="0" marL="0">
+              <a:buNone/>
+            </a:pPr>
+            <a:r>
+              <a:rPr lang="en-US" sz="2400" b="1" dirty="0">
+                <a:solidFill>
+                  <a:srgbClr val="111827"/>
+                </a:solidFill>
+                <a:latin typeface="Arial" pitchFamily="34" charset="0"/>
+                <a:ea typeface="Arial" pitchFamily="34" charset="-122"/>
+                <a:cs typeface="Arial" pitchFamily="34" charset="-120"/>
+              </a:rPr>
+              <a:t>Status de maturidade do produto</a:t>
+            </a:r>
+            <a:endParaRPr lang="en-US" sz="2400" dirty="0"/>
+          </a:p>
+        </p:txBody>
+      </p:sp>
+      <p:sp>
+        <p:nvSpPr>
+          <p:cNvPr id="5" name="Text 3"/>
+          <p:cNvSpPr/>
+          <p:nvPr/>
+        </p:nvSpPr>
+        <p:spPr>
+          <a:xfrm>
+            <a:off x="502920" y="1234440"/>
+            <a:ext cx="9784080" cy="420624"/>
+          </a:xfrm>
+          <a:prstGeom prst="rect">
+            <a:avLst/>
+          </a:prstGeom>
+          <a:noFill/>
+          <a:ln/>
+        </p:spPr>
+        <p:txBody>
+          <a:bodyPr wrap="square" lIns="0" tIns="0" rIns="0" bIns="0" rtlCol="0" anchor="ctr"/>
+          <a:lstStyle/>
+          <a:p>
+            <a:pPr indent="0" marL="0">
+              <a:buNone/>
+            </a:pPr>
+            <a:r>
+              <a:rPr lang="en-US" sz="1900" b="1" dirty="0">
+                <a:solidFill>
+                  <a:srgbClr val="111827"/>
+                </a:solidFill>
+                <a:latin typeface="Arial" pitchFamily="34" charset="0"/>
+                <a:ea typeface="Arial" pitchFamily="34" charset="-122"/>
+                <a:cs typeface="Arial" pitchFamily="34" charset="-120"/>
+              </a:rPr>
+              <a:t>Hoje o Aligna ja saiu da fase experimental e entrou em uma fase de produto operacional, mas ainda nao esta em maturidade plena de producao.</a:t>
+            </a:r>
+            <a:endParaRPr lang="en-US" sz="1900" dirty="0"/>
+          </a:p>
+        </p:txBody>
+      </p:sp>
+      <p:sp>
+        <p:nvSpPr>
+          <p:cNvPr id="6" name="Shape 4"/>
+          <p:cNvSpPr/>
+          <p:nvPr/>
+        </p:nvSpPr>
+        <p:spPr>
+          <a:xfrm>
+            <a:off x="502920" y="1828800"/>
+            <a:ext cx="2148840" cy="987552"/>
+          </a:xfrm>
+          <a:prstGeom prst="roundRect">
+            <a:avLst>
+              <a:gd name="adj" fmla="val 7407"/>
+            </a:avLst>
+          </a:prstGeom>
+          <a:solidFill>
+            <a:srgbClr val="EFF6FF"/>
+          </a:solidFill>
+          <a:ln w="12700">
+            <a:solidFill>
+              <a:srgbClr val="D9E2EC"/>
+            </a:solidFill>
+            <a:prstDash val="solid"/>
+          </a:ln>
+        </p:spPr>
+      </p:sp>
+      <p:sp>
+        <p:nvSpPr>
+          <p:cNvPr id="7" name="Shape 5"/>
+          <p:cNvSpPr/>
+          <p:nvPr/>
+        </p:nvSpPr>
+        <p:spPr>
+          <a:xfrm>
+            <a:off x="667512" y="1993392"/>
+            <a:ext cx="73152" cy="658368"/>
+          </a:xfrm>
+          <a:prstGeom prst="rect">
+            <a:avLst/>
+          </a:prstGeom>
+          <a:solidFill>
+            <a:srgbClr val="1D4ED8"/>
+          </a:solidFill>
+          <a:ln w="12700">
+            <a:solidFill>
+              <a:srgbClr val="1D4ED8">
+                <a:alpha val="0"/>
+              </a:srgbClr>
+            </a:solidFill>
+            <a:prstDash val="solid"/>
+          </a:ln>
+        </p:spPr>
+      </p:sp>
+      <p:sp>
+        <p:nvSpPr>
+          <p:cNvPr id="8" name="Text 6"/>
+          <p:cNvSpPr/>
+          <p:nvPr/>
+        </p:nvSpPr>
+        <p:spPr>
+          <a:xfrm>
+            <a:off x="850392" y="1993392"/>
+            <a:ext cx="1645920" cy="164592"/>
+          </a:xfrm>
+          <a:prstGeom prst="rect">
+            <a:avLst/>
+          </a:prstGeom>
+          <a:noFill/>
+          <a:ln/>
+        </p:spPr>
+        <p:txBody>
+          <a:bodyPr wrap="square" rtlCol="0" anchor="ctr"/>
+          <a:lstStyle/>
+          <a:p>
+            <a:pPr indent="0" marL="0">
+              <a:buNone/>
+            </a:pPr>
+            <a:r>
+              <a:rPr lang="en-US" sz="1000" b="1" dirty="0">
+                <a:solidFill>
+                  <a:srgbClr val="64748B"/>
+                </a:solidFill>
+                <a:latin typeface="Arial" pitchFamily="34" charset="0"/>
+                <a:ea typeface="Arial" pitchFamily="34" charset="-122"/>
+                <a:cs typeface="Arial" pitchFamily="34" charset="-120"/>
+              </a:rPr>
+              <a:t>Maturidade geral</a:t>
+            </a:r>
+            <a:endParaRPr lang="en-US" sz="1000" dirty="0"/>
+          </a:p>
+        </p:txBody>
+      </p:sp>
+      <p:sp>
+        <p:nvSpPr>
+          <p:cNvPr id="9" name="Text 7"/>
+          <p:cNvSpPr/>
+          <p:nvPr/>
+        </p:nvSpPr>
+        <p:spPr>
+          <a:xfrm>
+            <a:off x="850392" y="2231136"/>
+            <a:ext cx="1645920" cy="310896"/>
+          </a:xfrm>
+          <a:prstGeom prst="rect">
+            <a:avLst/>
+          </a:prstGeom>
+          <a:noFill/>
+          <a:ln/>
+        </p:spPr>
+        <p:txBody>
+          <a:bodyPr wrap="square" rtlCol="0" anchor="ctr"/>
+          <a:lstStyle/>
+          <a:p>
+            <a:pPr indent="0" marL="0">
+              <a:buNone/>
+            </a:pPr>
+            <a:r>
+              <a:rPr lang="en-US" sz="2200" b="1" dirty="0">
+                <a:solidFill>
+                  <a:srgbClr val="111827"/>
+                </a:solidFill>
+                <a:latin typeface="Arial" pitchFamily="34" charset="0"/>
+                <a:ea typeface="Arial" pitchFamily="34" charset="-122"/>
+                <a:cs typeface="Arial" pitchFamily="34" charset="-120"/>
+              </a:rPr>
+              <a:t>7 / 10</a:t>
+            </a:r>
+            <a:endParaRPr lang="en-US" sz="2200" dirty="0"/>
+          </a:p>
+        </p:txBody>
+      </p:sp>
+      <p:sp>
+        <p:nvSpPr>
+          <p:cNvPr id="10" name="Shape 8"/>
+          <p:cNvSpPr/>
+          <p:nvPr/>
+        </p:nvSpPr>
+        <p:spPr>
+          <a:xfrm>
+            <a:off x="2834640" y="1828800"/>
+            <a:ext cx="2468880" cy="987552"/>
+          </a:xfrm>
+          <a:prstGeom prst="roundRect">
+            <a:avLst>
+              <a:gd name="adj" fmla="val 7407"/>
+            </a:avLst>
+          </a:prstGeom>
+          <a:solidFill>
+            <a:srgbClr val="ECFDF5"/>
+          </a:solidFill>
+          <a:ln w="12700">
+            <a:solidFill>
+              <a:srgbClr val="D9E2EC"/>
+            </a:solidFill>
+            <a:prstDash val="solid"/>
+          </a:ln>
+        </p:spPr>
+      </p:sp>
+      <p:sp>
+        <p:nvSpPr>
+          <p:cNvPr id="11" name="Shape 9"/>
+          <p:cNvSpPr/>
+          <p:nvPr/>
+        </p:nvSpPr>
+        <p:spPr>
+          <a:xfrm>
+            <a:off x="2999232" y="1993392"/>
+            <a:ext cx="73152" cy="658368"/>
+          </a:xfrm>
+          <a:prstGeom prst="rect">
+            <a:avLst/>
+          </a:prstGeom>
+          <a:solidFill>
+            <a:srgbClr val="0F766E"/>
+          </a:solidFill>
+          <a:ln w="12700">
+            <a:solidFill>
+              <a:srgbClr val="0F766E">
+                <a:alpha val="0"/>
+              </a:srgbClr>
+            </a:solidFill>
+            <a:prstDash val="solid"/>
+          </a:ln>
+        </p:spPr>
+      </p:sp>
+      <p:sp>
+        <p:nvSpPr>
+          <p:cNvPr id="12" name="Text 10"/>
+          <p:cNvSpPr/>
+          <p:nvPr/>
+        </p:nvSpPr>
+        <p:spPr>
+          <a:xfrm>
+            <a:off x="3182112" y="1993392"/>
+            <a:ext cx="1965960" cy="164592"/>
+          </a:xfrm>
+          <a:prstGeom prst="rect">
+            <a:avLst/>
+          </a:prstGeom>
+          <a:noFill/>
+          <a:ln/>
+        </p:spPr>
+        <p:txBody>
+          <a:bodyPr wrap="square" rtlCol="0" anchor="ctr"/>
+          <a:lstStyle/>
+          <a:p>
+            <a:pPr indent="0" marL="0">
+              <a:buNone/>
+            </a:pPr>
+            <a:r>
+              <a:rPr lang="en-US" sz="1000" b="1" dirty="0">
+                <a:solidFill>
+                  <a:srgbClr val="64748B"/>
+                </a:solidFill>
+                <a:latin typeface="Arial" pitchFamily="34" charset="0"/>
+                <a:ea typeface="Arial" pitchFamily="34" charset="-122"/>
+                <a:cs typeface="Arial" pitchFamily="34" charset="-120"/>
+              </a:rPr>
+              <a:t>Fabrica de agentes</a:t>
+            </a:r>
+            <a:endParaRPr lang="en-US" sz="1000" dirty="0"/>
+          </a:p>
+        </p:txBody>
+      </p:sp>
+      <p:sp>
+        <p:nvSpPr>
+          <p:cNvPr id="13" name="Text 11"/>
+          <p:cNvSpPr/>
+          <p:nvPr/>
+        </p:nvSpPr>
+        <p:spPr>
+          <a:xfrm>
+            <a:off x="3182112" y="2231136"/>
+            <a:ext cx="1965960" cy="310896"/>
+          </a:xfrm>
+          <a:prstGeom prst="rect">
+            <a:avLst/>
+          </a:prstGeom>
+          <a:noFill/>
+          <a:ln/>
+        </p:spPr>
+        <p:txBody>
+          <a:bodyPr wrap="square" rtlCol="0" anchor="ctr"/>
+          <a:lstStyle/>
+          <a:p>
+            <a:pPr indent="0" marL="0">
+              <a:buNone/>
+            </a:pPr>
+            <a:r>
+              <a:rPr lang="en-US" sz="2200" b="1" dirty="0">
+                <a:solidFill>
+                  <a:srgbClr val="111827"/>
+                </a:solidFill>
+                <a:latin typeface="Arial" pitchFamily="34" charset="0"/>
+                <a:ea typeface="Arial" pitchFamily="34" charset="-122"/>
+                <a:cs typeface="Arial" pitchFamily="34" charset="-120"/>
+              </a:rPr>
+              <a:t>forte</a:t>
+            </a:r>
+            <a:endParaRPr lang="en-US" sz="2200" dirty="0"/>
+          </a:p>
+        </p:txBody>
+      </p:sp>
+      <p:sp>
+        <p:nvSpPr>
+          <p:cNvPr id="14" name="Shape 12"/>
+          <p:cNvSpPr/>
+          <p:nvPr/>
+        </p:nvSpPr>
+        <p:spPr>
+          <a:xfrm>
+            <a:off x="5486400" y="1828800"/>
+            <a:ext cx="2331720" cy="987552"/>
+          </a:xfrm>
+          <a:prstGeom prst="roundRect">
+            <a:avLst>
+              <a:gd name="adj" fmla="val 7407"/>
+            </a:avLst>
+          </a:prstGeom>
+          <a:solidFill>
+            <a:srgbClr val="FFF7ED"/>
+          </a:solidFill>
+          <a:ln w="12700">
+            <a:solidFill>
+              <a:srgbClr val="D9E2EC"/>
+            </a:solidFill>
+            <a:prstDash val="solid"/>
+          </a:ln>
+        </p:spPr>
+      </p:sp>
+      <p:sp>
+        <p:nvSpPr>
+          <p:cNvPr id="15" name="Shape 13"/>
+          <p:cNvSpPr/>
+          <p:nvPr/>
+        </p:nvSpPr>
+        <p:spPr>
+          <a:xfrm>
+            <a:off x="5650992" y="1993392"/>
+            <a:ext cx="73152" cy="658368"/>
+          </a:xfrm>
+          <a:prstGeom prst="rect">
+            <a:avLst/>
+          </a:prstGeom>
+          <a:solidFill>
+            <a:srgbClr val="B45309"/>
+          </a:solidFill>
+          <a:ln w="12700">
+            <a:solidFill>
+              <a:srgbClr val="B45309">
+                <a:alpha val="0"/>
+              </a:srgbClr>
+            </a:solidFill>
+            <a:prstDash val="solid"/>
+          </a:ln>
+        </p:spPr>
+      </p:sp>
+      <p:sp>
+        <p:nvSpPr>
+          <p:cNvPr id="16" name="Text 14"/>
+          <p:cNvSpPr/>
+          <p:nvPr/>
+        </p:nvSpPr>
+        <p:spPr>
+          <a:xfrm>
+            <a:off x="5833872" y="1993392"/>
+            <a:ext cx="1828800" cy="164592"/>
+          </a:xfrm>
+          <a:prstGeom prst="rect">
+            <a:avLst/>
+          </a:prstGeom>
+          <a:noFill/>
+          <a:ln/>
+        </p:spPr>
+        <p:txBody>
+          <a:bodyPr wrap="square" rtlCol="0" anchor="ctr"/>
+          <a:lstStyle/>
+          <a:p>
+            <a:pPr indent="0" marL="0">
+              <a:buNone/>
+            </a:pPr>
+            <a:r>
+              <a:rPr lang="en-US" sz="1000" b="1" dirty="0">
+                <a:solidFill>
+                  <a:srgbClr val="64748B"/>
+                </a:solidFill>
+                <a:latin typeface="Arial" pitchFamily="34" charset="0"/>
+                <a:ea typeface="Arial" pitchFamily="34" charset="-122"/>
+                <a:cs typeface="Arial" pitchFamily="34" charset="-120"/>
+              </a:rPr>
+              <a:t>Prontidao de producao</a:t>
+            </a:r>
+            <a:endParaRPr lang="en-US" sz="1000" dirty="0"/>
+          </a:p>
+        </p:txBody>
+      </p:sp>
+      <p:sp>
+        <p:nvSpPr>
+          <p:cNvPr id="17" name="Text 15"/>
+          <p:cNvSpPr/>
+          <p:nvPr/>
+        </p:nvSpPr>
+        <p:spPr>
+          <a:xfrm>
+            <a:off x="5833872" y="2231136"/>
+            <a:ext cx="1828800" cy="310896"/>
+          </a:xfrm>
+          <a:prstGeom prst="rect">
+            <a:avLst/>
+          </a:prstGeom>
+          <a:noFill/>
+          <a:ln/>
+        </p:spPr>
+        <p:txBody>
+          <a:bodyPr wrap="square" rtlCol="0" anchor="ctr"/>
+          <a:lstStyle/>
+          <a:p>
+            <a:pPr indent="0" marL="0">
+              <a:buNone/>
+            </a:pPr>
+            <a:r>
+              <a:rPr lang="en-US" sz="2200" b="1" dirty="0">
+                <a:solidFill>
+                  <a:srgbClr val="111827"/>
+                </a:solidFill>
+                <a:latin typeface="Arial" pitchFamily="34" charset="0"/>
+                <a:ea typeface="Arial" pitchFamily="34" charset="-122"/>
+                <a:cs typeface="Arial" pitchFamily="34" charset="-120"/>
+              </a:rPr>
+              <a:t>parcial</a:t>
+            </a:r>
+            <a:endParaRPr lang="en-US" sz="2200" dirty="0"/>
+          </a:p>
+        </p:txBody>
+      </p:sp>
+      <p:sp>
+        <p:nvSpPr>
+          <p:cNvPr id="18" name="Shape 16"/>
+          <p:cNvSpPr/>
+          <p:nvPr/>
+        </p:nvSpPr>
+        <p:spPr>
+          <a:xfrm>
+            <a:off x="8001000" y="1828800"/>
+            <a:ext cx="2788920" cy="987552"/>
+          </a:xfrm>
+          <a:prstGeom prst="roundRect">
+            <a:avLst>
+              <a:gd name="adj" fmla="val 7407"/>
+            </a:avLst>
+          </a:prstGeom>
+          <a:solidFill>
+            <a:srgbClr val="F5F3FF"/>
+          </a:solidFill>
+          <a:ln w="12700">
+            <a:solidFill>
+              <a:srgbClr val="D9E2EC"/>
+            </a:solidFill>
+            <a:prstDash val="solid"/>
+          </a:ln>
+        </p:spPr>
+      </p:sp>
+      <p:sp>
+        <p:nvSpPr>
+          <p:cNvPr id="19" name="Shape 17"/>
+          <p:cNvSpPr/>
+          <p:nvPr/>
+        </p:nvSpPr>
+        <p:spPr>
+          <a:xfrm>
+            <a:off x="8165592" y="1993392"/>
+            <a:ext cx="73152" cy="658368"/>
+          </a:xfrm>
+          <a:prstGeom prst="rect">
+            <a:avLst/>
+          </a:prstGeom>
+          <a:solidFill>
+            <a:srgbClr val="6D28D9"/>
+          </a:solidFill>
+          <a:ln w="12700">
+            <a:solidFill>
+              <a:srgbClr val="6D28D9">
+                <a:alpha val="0"/>
+              </a:srgbClr>
+            </a:solidFill>
+            <a:prstDash val="solid"/>
+          </a:ln>
+        </p:spPr>
+      </p:sp>
+      <p:sp>
+        <p:nvSpPr>
+          <p:cNvPr id="20" name="Text 18"/>
+          <p:cNvSpPr/>
+          <p:nvPr/>
+        </p:nvSpPr>
+        <p:spPr>
+          <a:xfrm>
+            <a:off x="8348472" y="1993392"/>
+            <a:ext cx="2286000" cy="164592"/>
+          </a:xfrm>
+          <a:prstGeom prst="rect">
+            <a:avLst/>
+          </a:prstGeom>
+          <a:noFill/>
+          <a:ln/>
+        </p:spPr>
+        <p:txBody>
+          <a:bodyPr wrap="square" rtlCol="0" anchor="ctr"/>
+          <a:lstStyle/>
+          <a:p>
+            <a:pPr indent="0" marL="0">
+              <a:buNone/>
+            </a:pPr>
+            <a:r>
+              <a:rPr lang="en-US" sz="1000" b="1" dirty="0">
+                <a:solidFill>
+                  <a:srgbClr val="64748B"/>
+                </a:solidFill>
+                <a:latin typeface="Arial" pitchFamily="34" charset="0"/>
+                <a:ea typeface="Arial" pitchFamily="34" charset="-122"/>
+                <a:cs typeface="Arial" pitchFamily="34" charset="-120"/>
+              </a:rPr>
+              <a:t>Principal proximo salto</a:t>
+            </a:r>
+            <a:endParaRPr lang="en-US" sz="1000" dirty="0"/>
+          </a:p>
+        </p:txBody>
+      </p:sp>
+      <p:sp>
+        <p:nvSpPr>
+          <p:cNvPr id="21" name="Text 19"/>
+          <p:cNvSpPr/>
+          <p:nvPr/>
+        </p:nvSpPr>
+        <p:spPr>
+          <a:xfrm>
+            <a:off x="8348472" y="2231136"/>
+            <a:ext cx="2286000" cy="310896"/>
+          </a:xfrm>
+          <a:prstGeom prst="rect">
+            <a:avLst/>
+          </a:prstGeom>
+          <a:noFill/>
+          <a:ln/>
+        </p:spPr>
+        <p:txBody>
+          <a:bodyPr wrap="square" rtlCol="0" anchor="ctr"/>
+          <a:lstStyle/>
+          <a:p>
+            <a:pPr indent="0" marL="0">
+              <a:buNone/>
+            </a:pPr>
+            <a:r>
+              <a:rPr lang="en-US" sz="2200" b="1" dirty="0">
+                <a:solidFill>
+                  <a:srgbClr val="111827"/>
+                </a:solidFill>
+                <a:latin typeface="Arial" pitchFamily="34" charset="0"/>
+                <a:ea typeface="Arial" pitchFamily="34" charset="-122"/>
+                <a:cs typeface="Arial" pitchFamily="34" charset="-120"/>
+              </a:rPr>
+              <a:t>convergencia do runtime</a:t>
+            </a:r>
+            <a:endParaRPr lang="en-US" sz="2200" dirty="0"/>
+          </a:p>
+        </p:txBody>
+      </p:sp>
+      <p:sp>
+        <p:nvSpPr>
+          <p:cNvPr id="22" name="Shape 20"/>
+          <p:cNvSpPr/>
+          <p:nvPr/>
+        </p:nvSpPr>
+        <p:spPr>
+          <a:xfrm>
+            <a:off x="502920" y="3154680"/>
+            <a:ext cx="3566160" cy="2423160"/>
+          </a:xfrm>
+          <a:prstGeom prst="roundRect">
+            <a:avLst>
+              <a:gd name="adj" fmla="val 3019"/>
+            </a:avLst>
+          </a:prstGeom>
+          <a:solidFill>
+            <a:srgbClr val="FFFFFF"/>
+          </a:solidFill>
+          <a:ln w="12700">
+            <a:solidFill>
+              <a:srgbClr val="D9E2EC"/>
+            </a:solidFill>
+            <a:prstDash val="solid"/>
+          </a:ln>
+        </p:spPr>
+      </p:sp>
+      <p:sp>
+        <p:nvSpPr>
+          <p:cNvPr id="23" name="Text 21"/>
+          <p:cNvSpPr/>
+          <p:nvPr/>
+        </p:nvSpPr>
+        <p:spPr>
+          <a:xfrm>
+            <a:off x="722376" y="3337560"/>
+            <a:ext cx="3127248" cy="201168"/>
+          </a:xfrm>
+          <a:prstGeom prst="rect">
+            <a:avLst/>
+          </a:prstGeom>
+          <a:noFill/>
+          <a:ln/>
+        </p:spPr>
+        <p:txBody>
+          <a:bodyPr wrap="square" rtlCol="0" anchor="ctr"/>
+          <a:lstStyle/>
+          <a:p>
+            <a:pPr indent="0" marL="0">
+              <a:buNone/>
+            </a:pPr>
+            <a:r>
+              <a:rPr lang="en-US" sz="1400" b="1" dirty="0">
+                <a:solidFill>
+                  <a:srgbClr val="111827"/>
+                </a:solidFill>
+                <a:latin typeface="Arial" pitchFamily="34" charset="0"/>
+                <a:ea typeface="Arial" pitchFamily="34" charset="-122"/>
+                <a:cs typeface="Arial" pitchFamily="34" charset="-120"/>
+              </a:rPr>
+              <a:t>Forcas atuais</a:t>
+            </a:r>
+            <a:endParaRPr lang="en-US" sz="1400" dirty="0"/>
+          </a:p>
+        </p:txBody>
+      </p:sp>
+      <p:sp>
+        <p:nvSpPr>
+          <p:cNvPr id="24" name="Text 22"/>
+          <p:cNvSpPr/>
+          <p:nvPr/>
+        </p:nvSpPr>
+        <p:spPr>
+          <a:xfrm>
+            <a:off x="704088" y="3657600"/>
+            <a:ext cx="3200400" cy="1580388"/>
+          </a:xfrm>
+          <a:prstGeom prst="rect">
+            <a:avLst/>
+          </a:prstGeom>
+          <a:noFill/>
+          <a:ln/>
+        </p:spPr>
+        <p:txBody>
+          <a:bodyPr wrap="square" lIns="0" tIns="0" rIns="0" bIns="0" rtlCol="0" anchor="t"/>
+          <a:lstStyle/>
+          <a:p>
+            <a:pPr marL="203200" indent="-203200">
+              <a:buSzPct val="100000"/>
+              <a:buChar char="•"/>
+            </a:pPr>
+            <a:r>
+              <a:rPr lang="en-US" sz="1300" dirty="0">
+                <a:solidFill>
+                  <a:srgbClr val="475569"/>
+                </a:solidFill>
+                <a:latin typeface="Arial" pitchFamily="34" charset="0"/>
+                <a:ea typeface="Arial" pitchFamily="34" charset="-122"/>
+                <a:cs typeface="Arial" pitchFamily="34" charset="-120"/>
+              </a:rPr>
+              <a:t>backlog, requisitos e arquitetura mais maduros</a:t>
+            </a:r>
+            <a:endParaRPr lang="en-US" sz="1300" dirty="0"/>
+          </a:p>
+          <a:p>
+            <a:pPr marL="203200" indent="-203200">
+              <a:buSzPct val="100000"/>
+              <a:buChar char="•"/>
+            </a:pPr>
+            <a:r>
+              <a:rPr lang="en-US" sz="1300" dirty="0">
+                <a:solidFill>
+                  <a:srgbClr val="475569"/>
+                </a:solidFill>
+                <a:latin typeface="Arial" pitchFamily="34" charset="0"/>
+                <a:ea typeface="Arial" pitchFamily="34" charset="-122"/>
+                <a:cs typeface="Arial" pitchFamily="34" charset="-120"/>
+              </a:rPr>
+              <a:t>geracao ja guiada por IR e composicao</a:t>
+            </a:r>
+            <a:endParaRPr lang="en-US" sz="1300" dirty="0"/>
+          </a:p>
+          <a:p>
+            <a:pPr marL="203200" indent="-203200">
+              <a:buSzPct val="100000"/>
+              <a:buChar char="•"/>
+            </a:pPr>
+            <a:r>
+              <a:rPr lang="en-US" sz="1300" dirty="0">
+                <a:solidFill>
+                  <a:srgbClr val="475569"/>
+                </a:solidFill>
+                <a:latin typeface="Arial" pitchFamily="34" charset="0"/>
+                <a:ea typeface="Arial" pitchFamily="34" charset="-122"/>
+                <a:cs typeface="Arial" pitchFamily="34" charset="-120"/>
+              </a:rPr>
+              <a:t>evals e comparabilidade reais</a:t>
+            </a:r>
+            <a:endParaRPr lang="en-US" sz="1300" dirty="0"/>
+          </a:p>
+          <a:p>
+            <a:pPr marL="203200" indent="-203200">
+              <a:buSzPct val="100000"/>
+              <a:buChar char="•"/>
+            </a:pPr>
+            <a:r>
+              <a:rPr lang="en-US" sz="1300" dirty="0">
+                <a:solidFill>
+                  <a:srgbClr val="475569"/>
+                </a:solidFill>
+                <a:latin typeface="Arial" pitchFamily="34" charset="0"/>
+                <a:ea typeface="Arial" pitchFamily="34" charset="-122"/>
+                <a:cs typeface="Arial" pitchFamily="34" charset="-120"/>
+              </a:rPr>
+              <a:t>seguranca basica e governanca mais fortes</a:t>
+            </a:r>
+            <a:endParaRPr lang="en-US" sz="1300" dirty="0"/>
+          </a:p>
+        </p:txBody>
+      </p:sp>
+      <p:sp>
+        <p:nvSpPr>
+          <p:cNvPr id="25" name="Shape 23"/>
+          <p:cNvSpPr/>
+          <p:nvPr/>
+        </p:nvSpPr>
+        <p:spPr>
+          <a:xfrm>
+            <a:off x="4297680" y="3154680"/>
+            <a:ext cx="3566160" cy="2423160"/>
+          </a:xfrm>
+          <a:prstGeom prst="roundRect">
+            <a:avLst>
+              <a:gd name="adj" fmla="val 3019"/>
+            </a:avLst>
+          </a:prstGeom>
+          <a:solidFill>
+            <a:srgbClr val="F8FAFC"/>
+          </a:solidFill>
+          <a:ln w="12700">
+            <a:solidFill>
+              <a:srgbClr val="D9E2EC"/>
+            </a:solidFill>
+            <a:prstDash val="solid"/>
+          </a:ln>
+        </p:spPr>
+      </p:sp>
+      <p:sp>
+        <p:nvSpPr>
+          <p:cNvPr id="26" name="Text 24"/>
+          <p:cNvSpPr/>
+          <p:nvPr/>
+        </p:nvSpPr>
+        <p:spPr>
+          <a:xfrm>
+            <a:off x="4517136" y="3337560"/>
+            <a:ext cx="3127248" cy="201168"/>
+          </a:xfrm>
+          <a:prstGeom prst="rect">
+            <a:avLst/>
+          </a:prstGeom>
+          <a:noFill/>
+          <a:ln/>
+        </p:spPr>
+        <p:txBody>
+          <a:bodyPr wrap="square" rtlCol="0" anchor="ctr"/>
+          <a:lstStyle/>
+          <a:p>
+            <a:pPr indent="0" marL="0">
+              <a:buNone/>
+            </a:pPr>
+            <a:r>
+              <a:rPr lang="en-US" sz="1400" b="1" dirty="0">
+                <a:solidFill>
+                  <a:srgbClr val="111827"/>
+                </a:solidFill>
+                <a:latin typeface="Arial" pitchFamily="34" charset="0"/>
+                <a:ea typeface="Arial" pitchFamily="34" charset="-122"/>
+                <a:cs typeface="Arial" pitchFamily="34" charset="-120"/>
+              </a:rPr>
+              <a:t>Fragilidades atuais</a:t>
+            </a:r>
+            <a:endParaRPr lang="en-US" sz="1400" dirty="0"/>
+          </a:p>
+        </p:txBody>
+      </p:sp>
+      <p:sp>
+        <p:nvSpPr>
+          <p:cNvPr id="27" name="Text 25"/>
+          <p:cNvSpPr/>
+          <p:nvPr/>
+        </p:nvSpPr>
+        <p:spPr>
+          <a:xfrm>
+            <a:off x="4498848" y="3657600"/>
+            <a:ext cx="3200400" cy="1580388"/>
+          </a:xfrm>
+          <a:prstGeom prst="rect">
+            <a:avLst/>
+          </a:prstGeom>
+          <a:noFill/>
+          <a:ln/>
+        </p:spPr>
+        <p:txBody>
+          <a:bodyPr wrap="square" lIns="0" tIns="0" rIns="0" bIns="0" rtlCol="0" anchor="t"/>
+          <a:lstStyle/>
+          <a:p>
+            <a:pPr marL="203200" indent="-203200">
+              <a:buSzPct val="100000"/>
+              <a:buChar char="•"/>
+            </a:pPr>
+            <a:r>
+              <a:rPr lang="en-US" sz="1300" dirty="0">
+                <a:solidFill>
+                  <a:srgbClr val="475569"/>
+                </a:solidFill>
+                <a:latin typeface="Arial" pitchFamily="34" charset="0"/>
+                <a:ea typeface="Arial" pitchFamily="34" charset="-122"/>
+                <a:cs typeface="Arial" pitchFamily="34" charset="-120"/>
+              </a:rPr>
+              <a:t>alguns fluxos ainda exigem reconciliacao manual</a:t>
+            </a:r>
+            <a:endParaRPr lang="en-US" sz="1300" dirty="0"/>
+          </a:p>
+          <a:p>
+            <a:pPr marL="203200" indent="-203200">
+              <a:buSzPct val="100000"/>
+              <a:buChar char="•"/>
+            </a:pPr>
+            <a:r>
+              <a:rPr lang="en-US" sz="1300" dirty="0">
+                <a:solidFill>
+                  <a:srgbClr val="475569"/>
+                </a:solidFill>
+                <a:latin typeface="Arial" pitchFamily="34" charset="0"/>
+                <a:ea typeface="Arial" pitchFamily="34" charset="-122"/>
+                <a:cs typeface="Arial" pitchFamily="34" charset="-120"/>
+              </a:rPr>
+              <a:t>readiness de producao ainda nao esta fechado</a:t>
+            </a:r>
+            <a:endParaRPr lang="en-US" sz="1300" dirty="0"/>
+          </a:p>
+          <a:p>
+            <a:pPr marL="203200" indent="-203200">
+              <a:buSzPct val="100000"/>
+              <a:buChar char="•"/>
+            </a:pPr>
+            <a:r>
+              <a:rPr lang="en-US" sz="1300" dirty="0">
+                <a:solidFill>
+                  <a:srgbClr val="475569"/>
+                </a:solidFill>
+                <a:latin typeface="Arial" pitchFamily="34" charset="0"/>
+                <a:ea typeface="Arial" pitchFamily="34" charset="-122"/>
+                <a:cs typeface="Arial" pitchFamily="34" charset="-120"/>
+              </a:rPr>
+              <a:t>runtime legado e moderno ainda convivem</a:t>
+            </a:r>
+            <a:endParaRPr lang="en-US" sz="1300" dirty="0"/>
+          </a:p>
+          <a:p>
+            <a:pPr marL="203200" indent="-203200">
+              <a:buSzPct val="100000"/>
+              <a:buChar char="•"/>
+            </a:pPr>
+            <a:r>
+              <a:rPr lang="en-US" sz="1300" dirty="0">
+                <a:solidFill>
+                  <a:srgbClr val="475569"/>
+                </a:solidFill>
+                <a:latin typeface="Arial" pitchFamily="34" charset="0"/>
+                <a:ea typeface="Arial" pitchFamily="34" charset="-122"/>
+                <a:cs typeface="Arial" pitchFamily="34" charset="-120"/>
+              </a:rPr>
+              <a:t>generalizacao ainda precisa de mais prova em casos novos</a:t>
+            </a:r>
+            <a:endParaRPr lang="en-US" sz="1300" dirty="0"/>
+          </a:p>
+        </p:txBody>
+      </p:sp>
+      <p:sp>
+        <p:nvSpPr>
+          <p:cNvPr id="28" name="Shape 26"/>
+          <p:cNvSpPr/>
+          <p:nvPr/>
+        </p:nvSpPr>
+        <p:spPr>
+          <a:xfrm>
+            <a:off x="8092440" y="3154680"/>
+            <a:ext cx="3611880" cy="2423160"/>
+          </a:xfrm>
+          <a:prstGeom prst="roundRect">
+            <a:avLst>
+              <a:gd name="adj" fmla="val 3019"/>
+            </a:avLst>
+          </a:prstGeom>
+          <a:solidFill>
+            <a:srgbClr val="EFF6FF"/>
+          </a:solidFill>
+          <a:ln w="12700">
+            <a:solidFill>
+              <a:srgbClr val="D9E2EC"/>
+            </a:solidFill>
+            <a:prstDash val="solid"/>
+          </a:ln>
+        </p:spPr>
+      </p:sp>
+      <p:sp>
+        <p:nvSpPr>
+          <p:cNvPr id="29" name="Text 27"/>
+          <p:cNvSpPr/>
+          <p:nvPr/>
+        </p:nvSpPr>
+        <p:spPr>
+          <a:xfrm>
+            <a:off x="8311896" y="3337560"/>
+            <a:ext cx="3172968" cy="201168"/>
+          </a:xfrm>
+          <a:prstGeom prst="rect">
+            <a:avLst/>
+          </a:prstGeom>
+          <a:noFill/>
+          <a:ln/>
+        </p:spPr>
+        <p:txBody>
+          <a:bodyPr wrap="square" rtlCol="0" anchor="ctr"/>
+          <a:lstStyle/>
+          <a:p>
+            <a:pPr indent="0" marL="0">
+              <a:buNone/>
+            </a:pPr>
+            <a:r>
+              <a:rPr lang="en-US" sz="1400" b="1" dirty="0">
+                <a:solidFill>
+                  <a:srgbClr val="111827"/>
+                </a:solidFill>
+                <a:latin typeface="Arial" pitchFamily="34" charset="0"/>
+                <a:ea typeface="Arial" pitchFamily="34" charset="-122"/>
+                <a:cs typeface="Arial" pitchFamily="34" charset="-120"/>
+              </a:rPr>
+              <a:t>Leitura executiva</a:t>
+            </a:r>
+            <a:endParaRPr lang="en-US" sz="1400" dirty="0"/>
+          </a:p>
+        </p:txBody>
+      </p:sp>
+      <p:sp>
+        <p:nvSpPr>
+          <p:cNvPr id="30" name="Text 28"/>
+          <p:cNvSpPr/>
+          <p:nvPr/>
+        </p:nvSpPr>
+        <p:spPr>
+          <a:xfrm>
+            <a:off x="8311896" y="3657600"/>
+            <a:ext cx="3172968" cy="1783080"/>
+          </a:xfrm>
+          <a:prstGeom prst="rect">
+            <a:avLst/>
+          </a:prstGeom>
+          <a:noFill/>
+          <a:ln/>
+        </p:spPr>
+        <p:txBody>
+          <a:bodyPr wrap="square" lIns="0" tIns="0" rIns="0" bIns="0" rtlCol="0" anchor="t"/>
+          <a:lstStyle/>
+          <a:p>
+            <a:pPr indent="0" marL="0">
+              <a:buNone/>
+            </a:pPr>
+            <a:r>
+              <a:rPr lang="en-US" sz="1300" dirty="0">
+                <a:solidFill>
+                  <a:srgbClr val="475569"/>
+                </a:solidFill>
+                <a:latin typeface="Arial" pitchFamily="34" charset="0"/>
+                <a:ea typeface="Arial" pitchFamily="34" charset="-122"/>
+                <a:cs typeface="Arial" pitchFamily="34" charset="-120"/>
+              </a:rPr>
+              <a:t>O produto ja demonstra valor real, fluxo consistente e evolucao arquitetural clara. O risco atual nao e mais viabilidade, e sim robustez operacional para escala e producao.</a:t>
+            </a:r>
+            <a:endParaRPr lang="en-US" sz="1300" dirty="0"/>
+          </a:p>
+        </p:txBody>
+      </p:sp>
+      <p:sp>
+        <p:nvSpPr>
+          <p:cNvPr id="31" name="Text 29"/>
+          <p:cNvSpPr/>
+          <p:nvPr/>
+        </p:nvSpPr>
+        <p:spPr>
+          <a:xfrm>
+            <a:off x="640080" y="5870448"/>
+            <a:ext cx="10972800" cy="320040"/>
+          </a:xfrm>
+          <a:prstGeom prst="rect">
+            <a:avLst/>
+          </a:prstGeom>
+          <a:noFill/>
+          <a:ln/>
+        </p:spPr>
+        <p:txBody>
+          <a:bodyPr wrap="square" lIns="0" tIns="0" rIns="0" bIns="0" rtlCol="0" anchor="ctr"/>
+          <a:lstStyle/>
+          <a:p>
+            <a:pPr indent="0" marL="0">
+              <a:buNone/>
+            </a:pPr>
+            <a:r>
+              <a:rPr lang="en-US" sz="1350" b="1" dirty="0">
+                <a:solidFill>
+                  <a:srgbClr val="111827"/>
+                </a:solidFill>
+                <a:latin typeface="Arial" pitchFamily="34" charset="0"/>
+                <a:ea typeface="Arial" pitchFamily="34" charset="-122"/>
+                <a:cs typeface="Arial" pitchFamily="34" charset="-120"/>
+              </a:rPr>
+              <a:t>Sintese: o Aligna hoje pode ser apresentado como plataforma operacional em maturacao avancada, com base tecnica forte e pendencias concentradas em robustez final de runtime e readiness.</a:t>
+            </a:r>
+            <a:endParaRPr lang="en-US" sz="1350" dirty="0"/>
+          </a:p>
+        </p:txBody>
+      </p:sp>
+      <p:sp>
+        <p:nvSpPr>
+          <p:cNvPr id="32" name="Text 30"/>
+          <p:cNvSpPr/>
+          <p:nvPr/>
+        </p:nvSpPr>
+        <p:spPr>
+          <a:xfrm>
+            <a:off x="502920" y="6455664"/>
+            <a:ext cx="3657600" cy="146304"/>
+          </a:xfrm>
+          <a:prstGeom prst="rect">
+            <a:avLst/>
+          </a:prstGeom>
+          <a:noFill/>
+          <a:ln/>
+        </p:spPr>
+        <p:txBody>
+          <a:bodyPr wrap="square" rtlCol="0" anchor="ctr"/>
+          <a:lstStyle/>
+          <a:p>
+            <a:pPr indent="0" marL="0">
+              <a:buNone/>
+            </a:pPr>
+            <a:r>
+              <a:rPr lang="en-US" sz="900" dirty="0">
+                <a:solidFill>
+                  <a:srgbClr val="64748B"/>
+                </a:solidFill>
+                <a:latin typeface="Arial" pitchFamily="34" charset="0"/>
+                <a:ea typeface="Arial" pitchFamily="34" charset="-122"/>
+                <a:cs typeface="Arial" pitchFamily="34" charset="-120"/>
+              </a:rPr>
+              <a:t>Aligna | apresentacao academica | 12</a:t>
+            </a:r>
+            <a:endParaRPr lang="en-US" sz="900" dirty="0"/>
+          </a:p>
+        </p:txBody>
+      </p:sp>
+    </p:spTree>
+  </p:cSld>
+  <p:clrMapOvr>
+    <a:masterClrMapping/>
+  </p:clrMapOvr>
+</p:sld>
+</file>
+
+<file path=ppt/slides/slide13.xml><?xml version="1.0" encoding="utf-8"?>
+<p:sld xmlns:a="http://schemas.openxmlformats.org/drawingml/2006/main" xmlns:r="http://schemas.openxmlformats.org/officeDocument/2006/relationships" xmlns:p="http://schemas.openxmlformats.org/presentationml/2006/main">
+  <p:cSld name="Slide 13">
+    <p:bg>
+      <p:bgPr>
+        <a:solidFill>
           <a:srgbClr val="0F172A"/>
         </a:solidFill>
       </p:bgPr>
@@ -4310,7 +5606,7 @@
                 <a:ea typeface="Arial" pitchFamily="34" charset="-122"/>
                 <a:cs typeface="Arial" pitchFamily="34" charset="-120"/>
               </a:rPr>
-              <a:t>Aligna | apresentacao academica | 12</a:t>
+              <a:t>Aligna | apresentacao academica | 13</a:t>
             </a:r>
             <a:endParaRPr lang="en-US" sz="900" dirty="0"/>
           </a:p>

</xml_diff>